<commit_message>
feat: add LaTeX report, presentation, and compiled PDF assets for digital image processing midterm assignment
</commit_message>
<xml_diff>
--- a/laporan/ppt/presentasi-uts-pcd-kelompok-9.pptx
+++ b/laporan/ppt/presentasi-uts-pcd-kelompok-9.pptx
@@ -9043,6 +9043,7 @@
               </a:defRPr>
             </a:defPPr>
             <a:lvl1pPr algn="l">
+              <a:buNone/>
               <a:defRPr sz="2250">
                 <a:solidFill>
                   <a:srgbClr val="F4F8FF"/>
@@ -9053,6 +9054,7 @@
               </a:defRPr>
             </a:lvl1pPr>
             <a:lvl2pPr algn="l">
+              <a:buNone/>
               <a:defRPr sz="2250">
                 <a:solidFill>
                   <a:srgbClr val="F4F8FF"/>
@@ -9063,6 +9065,7 @@
               </a:defRPr>
             </a:lvl2pPr>
             <a:lvl3pPr algn="l">
+              <a:buNone/>
               <a:defRPr sz="2250">
                 <a:solidFill>
                   <a:srgbClr val="F4F8FF"/>
@@ -9073,6 +9076,7 @@
               </a:defRPr>
             </a:lvl3pPr>
             <a:lvl4pPr algn="l">
+              <a:buNone/>
               <a:defRPr sz="2250">
                 <a:solidFill>
                   <a:srgbClr val="F4F8FF"/>
@@ -9083,6 +9087,7 @@
               </a:defRPr>
             </a:lvl4pPr>
             <a:lvl5pPr algn="l">
+              <a:buNone/>
               <a:defRPr sz="2250">
                 <a:solidFill>
                   <a:srgbClr val="F4F8FF"/>
@@ -9093,6 +9098,7 @@
               </a:defRPr>
             </a:lvl5pPr>
             <a:lvl6pPr algn="l">
+              <a:buNone/>
               <a:defRPr sz="2250">
                 <a:solidFill>
                   <a:srgbClr val="F4F8FF"/>
@@ -9103,6 +9109,7 @@
               </a:defRPr>
             </a:lvl6pPr>
             <a:lvl7pPr algn="l">
+              <a:buNone/>
               <a:defRPr sz="2250">
                 <a:solidFill>
                   <a:srgbClr val="F4F8FF"/>
@@ -9113,6 +9120,7 @@
               </a:defRPr>
             </a:lvl7pPr>
             <a:lvl8pPr algn="l">
+              <a:buNone/>
               <a:defRPr sz="2250">
                 <a:solidFill>
                   <a:srgbClr val="F4F8FF"/>
@@ -9123,6 +9131,7 @@
               </a:defRPr>
             </a:lvl8pPr>
             <a:lvl9pPr algn="l">
+              <a:buNone/>
               <a:defRPr sz="2250">
                 <a:solidFill>
                   <a:srgbClr val="F4F8FF"/>
@@ -9135,6 +9144,7 @@
           </a:lstStyle>
           <a:p xmlns:a="http://schemas.openxmlformats.org/drawingml/2006/main">
             <a:pPr algn="l">
+              <a:buNone/>
               <a:defRPr sz="2250">
                 <a:solidFill>
                   <a:srgbClr val="F4F8FF"/>
@@ -9153,11 +9163,12 @@
                 <a:ea typeface="Arial"/>
                 <a:cs typeface="Arial"/>
               </a:rPr>
-              <a:t>Dua filter pada citra yang sama</a:t>
+              <a:t>a. Baca citra, ubah ke grayscale.</a:t>
             </a:r>
           </a:p>
           <a:p xmlns:a="http://schemas.openxmlformats.org/drawingml/2006/main">
             <a:pPr algn="l">
+              <a:buNone/>
               <a:defRPr sz="2250">
                 <a:solidFill>
                   <a:srgbClr val="F4F8FF"/>
@@ -9176,16 +9187,17 @@
                 <a:ea typeface="Arial"/>
                 <a:cs typeface="Arial"/>
               </a:rPr>
-              <a:t>σ = 0,1 dan σ = 0,2 piksel</a:t>
+              <a:t>b. LoG σ = 0,1, simpan im1.</a:t>
             </a:r>
           </a:p>
           <a:p xmlns:a="http://schemas.openxmlformats.org/drawingml/2006/main">
             <a:r>
-              <a:t/>
+              <a:t>c. LoG σ = 0,2, simpan im2.</a:t>
             </a:r>
           </a:p>
           <a:p xmlns:a="http://schemas.openxmlformats.org/drawingml/2006/main">
             <a:pPr algn="l">
+              <a:buNone/>
               <a:defRPr sz="2250">
                 <a:solidFill>
                   <a:srgbClr val="F4F8FF"/>
@@ -9204,7 +9216,7 @@
                 <a:ea typeface="Arial"/>
                 <a:cs typeface="Arial"/>
               </a:rPr>
-              <a:t>Selisih bertanda: im1 − im2</a:t>
+              <a:t>d. Hitung im1 − im2, simpan hasil.</a:t>
             </a:r>
           </a:p>
         </p:txBody>

</xml_diff>